<commit_message>
Beacon v2.3: 30s teaser + deck cosmetic polish (slides 2/4/7)
</commit_message>
<xml_diff>
--- a/docs/downloads/AIGovOps_Beacon_Pitch.pptx
+++ b/docs/downloads/AIGovOps_Beacon_Pitch.pptx
@@ -2626,7 +2626,7 @@
                 <a:ea typeface="Trebuchet MS" pitchFamily="34" charset="-122"/>
                 <a:cs typeface="Trebuchet MS" pitchFamily="34" charset="-120"/>
               </a:rPr>
-              <a:t>Twenty-three frameworks. One score command.</a:t>
+              <a:t>23 frameworks built in. Yours plugs right in.</a:t>
             </a:r>
             <a:endParaRPr lang="en-US" sz="3200" dirty="0"/>
           </a:p>
@@ -6742,8 +6742,8 @@
         </p:nvSpPr>
         <p:spPr>
           <a:xfrm>
-            <a:off x="655168" y="2286000"/>
-            <a:ext cx="3108960" cy="365760"/>
+            <a:off x="655168" y="2331720"/>
+            <a:ext cx="3108960" cy="320040"/>
           </a:xfrm>
           <a:prstGeom prst="rect">
             <a:avLst/>
@@ -6782,7 +6782,7 @@
         <p:spPr>
           <a:xfrm>
             <a:off x="655168" y="2743200"/>
-            <a:ext cx="3108960" cy="822960"/>
+            <a:ext cx="3108960" cy="777240"/>
           </a:xfrm>
           <a:prstGeom prst="rect">
             <a:avLst/>
@@ -6820,7 +6820,7 @@
         </p:nvSpPr>
         <p:spPr>
           <a:xfrm>
-            <a:off x="655168" y="3703320"/>
+            <a:off x="655168" y="3611880"/>
             <a:ext cx="3108960" cy="1920240"/>
           </a:xfrm>
           <a:prstGeom prst="rect">
@@ -6830,7 +6830,7 @@
           <a:ln/>
         </p:spPr>
         <p:txBody>
-          <a:bodyPr wrap="square" rtlCol="0" anchor="ctr"/>
+          <a:bodyPr wrap="square" rtlCol="0" anchor="t"/>
           <a:lstStyle/>
           <a:p>
             <a:pPr indent="0" marL="0">
@@ -6884,8 +6884,8 @@
         </p:nvSpPr>
         <p:spPr>
           <a:xfrm>
-            <a:off x="4541368" y="2286000"/>
-            <a:ext cx="3108960" cy="365760"/>
+            <a:off x="4541368" y="2331720"/>
+            <a:ext cx="3108960" cy="320040"/>
           </a:xfrm>
           <a:prstGeom prst="rect">
             <a:avLst/>
@@ -6924,7 +6924,7 @@
         <p:spPr>
           <a:xfrm>
             <a:off x="4541368" y="2743200"/>
-            <a:ext cx="3108960" cy="822960"/>
+            <a:ext cx="3108960" cy="777240"/>
           </a:xfrm>
           <a:prstGeom prst="rect">
             <a:avLst/>
@@ -6962,7 +6962,7 @@
         </p:nvSpPr>
         <p:spPr>
           <a:xfrm>
-            <a:off x="4541368" y="3703320"/>
+            <a:off x="4541368" y="3611880"/>
             <a:ext cx="3108960" cy="1920240"/>
           </a:xfrm>
           <a:prstGeom prst="rect">
@@ -6972,7 +6972,7 @@
           <a:ln/>
         </p:spPr>
         <p:txBody>
-          <a:bodyPr wrap="square" rtlCol="0" anchor="ctr"/>
+          <a:bodyPr wrap="square" rtlCol="0" anchor="t"/>
           <a:lstStyle/>
           <a:p>
             <a:pPr indent="0" marL="0">
@@ -7026,8 +7026,8 @@
         </p:nvSpPr>
         <p:spPr>
           <a:xfrm>
-            <a:off x="8427568" y="2286000"/>
-            <a:ext cx="3108960" cy="365760"/>
+            <a:off x="8427568" y="2331720"/>
+            <a:ext cx="3108960" cy="320040"/>
           </a:xfrm>
           <a:prstGeom prst="rect">
             <a:avLst/>
@@ -7066,7 +7066,7 @@
         <p:spPr>
           <a:xfrm>
             <a:off x="8427568" y="2743200"/>
-            <a:ext cx="3108960" cy="822960"/>
+            <a:ext cx="3108960" cy="777240"/>
           </a:xfrm>
           <a:prstGeom prst="rect">
             <a:avLst/>
@@ -7104,7 +7104,7 @@
         </p:nvSpPr>
         <p:spPr>
           <a:xfrm>
-            <a:off x="8427568" y="3703320"/>
+            <a:off x="8427568" y="3611880"/>
             <a:ext cx="3108960" cy="1920240"/>
           </a:xfrm>
           <a:prstGeom prst="rect">
@@ -7114,7 +7114,7 @@
           <a:ln/>
         </p:spPr>
         <p:txBody>
-          <a:bodyPr wrap="square" rtlCol="0" anchor="ctr"/>
+          <a:bodyPr wrap="square" rtlCol="0" anchor="t"/>
           <a:lstStyle/>
           <a:p>
             <a:pPr indent="0" marL="0">
@@ -8957,7 +8957,7 @@
                 <a:ea typeface="Calibri" pitchFamily="34" charset="-122"/>
                 <a:cs typeface="Calibri" pitchFamily="34" charset="-120"/>
               </a:rPr>
-              <a:t>Sign every prompt and response. Replay any conversation when legal asks.</a:t>
+              <a:t>Sign every prompt and response. Replay any conversation when legal asks for it.</a:t>
             </a:r>
             <a:endParaRPr lang="en-US" sz="1400" dirty="0"/>
           </a:p>
@@ -9060,7 +9060,7 @@
                 <a:ea typeface="Calibri" pitchFamily="34" charset="-122"/>
                 <a:cs typeface="Calibri" pitchFamily="34" charset="-120"/>
               </a:rPr>
-              <a:t>Bundle receipts per session. Hand them to regulators on demand.</a:t>
+              <a:t>Bundle receipts per session. Hand them to regulators on demand, without delay.</a:t>
             </a:r>
             <a:endParaRPr lang="en-US" sz="1400" dirty="0"/>
           </a:p>
@@ -9163,7 +9163,7 @@
                 <a:ea typeface="Calibri" pitchFamily="34" charset="-122"/>
                 <a:cs typeface="Calibri" pitchFamily="34" charset="-120"/>
               </a:rPr>
-              <a:t>Log routing decisions across agents. Detect drift between runs.</a:t>
+              <a:t>Log routing decisions across agents. Detect drift between runs, before users do.</a:t>
             </a:r>
             <a:endParaRPr lang="en-US" sz="1400" dirty="0"/>
           </a:p>
@@ -9266,7 +9266,7 @@
                 <a:ea typeface="Calibri" pitchFamily="34" charset="-122"/>
                 <a:cs typeface="Calibri" pitchFamily="34" charset="-120"/>
               </a:rPr>
-              <a:t>Lending, healthcare, hiring — every decision auditable and replayable.</a:t>
+              <a:t>Lending, healthcare, hiring — every decision auditable, verifiable, replayable.</a:t>
             </a:r>
             <a:endParaRPr lang="en-US" sz="1400" dirty="0"/>
           </a:p>
@@ -9369,7 +9369,7 @@
                 <a:ea typeface="Calibri" pitchFamily="34" charset="-122"/>
                 <a:cs typeface="Calibri" pitchFamily="34" charset="-120"/>
               </a:rPr>
-              <a:t>Track every model in production, with provenance, owners, and risk class.</a:t>
+              <a:t>Track every model in production, with provenance, owners, and a live risk class.</a:t>
             </a:r>
             <a:endParaRPr lang="en-US" sz="1400" dirty="0"/>
           </a:p>
@@ -9472,7 +9472,7 @@
                 <a:ea typeface="Calibri" pitchFamily="34" charset="-122"/>
                 <a:cs typeface="Calibri" pitchFamily="34" charset="-120"/>
               </a:rPr>
-              <a:t>Hand the auditor a bundle they can verify themselves. No portal logins.</a:t>
+              <a:t>Hand the auditor a bundle they can verify themselves. No portal logins required.</a:t>
             </a:r>
             <a:endParaRPr lang="en-US" sz="1400" dirty="0"/>
           </a:p>

</xml_diff>

<commit_message>
deck: regenerate the pitch .pptx with corrected org links + fix the output path
The committed AIGovOps_Beacon_Pitch.pptx still embedded the pre-move links
(bobrapp.github.io/aigovops-beacon, github.com/bobrapp/aigovops-beacon). PR #24
corrected the source (build_deck_v23.js) but couldn't touch the binary; this
rebuilds it from that corrected source (pptxgenjs, 14 slides, 0 bobrapp refs).

Also fixes the script's hardcoded /home/user/workspace/ output path (a leftover
from the original build sandbox — it never wrote into the repo) to the
documented docs/downloads/ location, so the deck is reproducible with a plain
`node build_deck_v23.js` per tools/README.md.

The .pdf exports and the _Big/_Small variants are NOT regenerated here — see the
PR for why (no in-repo generator / no LibreOffice in this environment).

Co-Authored-By: Claude Opus 4.8 <noreply@anthropic.com>
</commit_message>
<xml_diff>
--- a/docs/downloads/AIGovOps_Beacon_Pitch.pptx
+++ b/docs/downloads/AIGovOps_Beacon_Pitch.pptx
@@ -2060,7 +2060,7 @@
         </p:nvSpPr>
         <p:spPr>
           <a:xfrm>
-            <a:off x="640080" y="1737360"/>
+            <a:off x="640080" y="1828800"/>
             <a:ext cx="10972800" cy="1463040"/>
           </a:xfrm>
           <a:prstGeom prst="rect">
@@ -2099,7 +2099,7 @@
         </p:nvSpPr>
         <p:spPr>
           <a:xfrm>
-            <a:off x="640080" y="3291840"/>
+            <a:off x="640080" y="3383280"/>
             <a:ext cx="10972800" cy="548640"/>
           </a:xfrm>
           <a:prstGeom prst="rect">
@@ -2138,7 +2138,7 @@
         </p:nvSpPr>
         <p:spPr>
           <a:xfrm>
-            <a:off x="640080" y="3840480"/>
+            <a:off x="640080" y="3931920"/>
             <a:ext cx="10972800" cy="365760"/>
           </a:xfrm>
           <a:prstGeom prst="rect">
@@ -2163,7 +2163,7 @@
                 <a:ea typeface="Calibri" pitchFamily="34" charset="-122"/>
                 <a:cs typeface="Calibri" pitchFamily="34" charset="-120"/>
               </a:rPr>
-              <a:t>v2.5 · Small edition · Apache 2.0 · No SaaS lock-in</a:t>
+              <a:t>v2.3  ·  Apache 2.0  ·  No SaaS lock-in</a:t>
             </a:r>
             <a:endParaRPr lang="en-US" sz="1400" dirty="0"/>
           </a:p>
@@ -2177,7 +2177,7 @@
         </p:nvSpPr>
         <p:spPr>
           <a:xfrm>
-            <a:off x="640080" y="4846320"/>
+            <a:off x="640080" y="4937760"/>
             <a:ext cx="10972800" cy="411480"/>
           </a:xfrm>
           <a:prstGeom prst="rect">
@@ -2240,7 +2240,7 @@
                 <a:latin typeface="Calibri" pitchFamily="34" charset="0"/>
                 <a:ea typeface="Calibri" pitchFamily="34" charset="-122"/>
                 <a:cs typeface="Calibri" pitchFamily="34" charset="-120"/>
-                <a:hlinkClick r:id="rId1" invalidUrl="" action="" tgtFrame="" tooltip="Open the repo" history="1" highlightClick="0" endSnd="0">
+                <a:hlinkClick r:id="rId1" invalidUrl="" action="" tgtFrame="" tooltip="" history="1" highlightClick="0" endSnd="0">
                   <a:extLst>
                     <a:ext uri="{A12FA001-AC4F-418D-AE19-62706E023703}">
                       <ahyp:hlinkClr xmlns:ahyp="http://schemas.microsoft.com/office/drawing/2018/hyperlinkcolor" val="tx"/>
@@ -2248,7 +2248,7 @@
                   </a:extLst>
                 </a:hlinkClick>
               </a:rPr>
-              <a:t>github.com/bobrapp/aigovops-beacon</a:t>
+              <a:t>github.com/aigovops-foundation/aigovops-beacon</a:t>
             </a:r>
             <a:pPr indent="0" marL="0">
               <a:buNone/>
@@ -2275,7 +2275,7 @@
                 <a:latin typeface="Calibri" pitchFamily="34" charset="0"/>
                 <a:ea typeface="Calibri" pitchFamily="34" charset="-122"/>
                 <a:cs typeface="Calibri" pitchFamily="34" charset="-120"/>
-                <a:hlinkClick r:id="rId2" invalidUrl="" action="" tgtFrame="" tooltip="Foundation" history="1" highlightClick="0" endSnd="0">
+                <a:hlinkClick r:id="rId2" invalidUrl="" action="" tgtFrame="" tooltip="" history="1" highlightClick="0" endSnd="0">
                   <a:extLst>
                     <a:ext uri="{A12FA001-AC4F-418D-AE19-62706E023703}">
                       <ahyp:hlinkClr xmlns:ahyp="http://schemas.microsoft.com/office/drawing/2018/hyperlinkcolor" val="tx"/>
@@ -2284,41 +2284,6 @@
                 </a:hlinkClick>
               </a:rPr>
               <a:t>aigovopsfoundation.org</a:t>
-            </a:r>
-            <a:pPr indent="0" marL="0">
-              <a:buNone/>
-            </a:pPr>
-            <a:r>
-              <a:rPr lang="en-US" sz="1400" dirty="0">
-                <a:solidFill>
-                  <a:srgbClr val="C7E7EA"/>
-                </a:solidFill>
-                <a:latin typeface="Calibri" pitchFamily="34" charset="0"/>
-                <a:ea typeface="Calibri" pitchFamily="34" charset="-122"/>
-                <a:cs typeface="Calibri" pitchFamily="34" charset="-120"/>
-              </a:rPr>
-              <a:t>        </a:t>
-            </a:r>
-            <a:pPr indent="0" marL="0">
-              <a:buNone/>
-            </a:pPr>
-            <a:r>
-              <a:rPr lang="en-US" sz="1400" u="sng" dirty="0">
-                <a:solidFill>
-                  <a:srgbClr val="C7E7EA"/>
-                </a:solidFill>
-                <a:latin typeface="Calibri" pitchFamily="34" charset="0"/>
-                <a:ea typeface="Calibri" pitchFamily="34" charset="-122"/>
-                <a:cs typeface="Calibri" pitchFamily="34" charset="-120"/>
-                <a:hlinkClick r:id="rId3" invalidUrl="" action="" tgtFrame="" tooltip="GitHub Pages site" history="1" highlightClick="0" endSnd="0">
-                  <a:extLst>
-                    <a:ext uri="{A12FA001-AC4F-418D-AE19-62706E023703}">
-                      <ahyp:hlinkClr xmlns:ahyp="http://schemas.microsoft.com/office/drawing/2018/hyperlinkcolor" val="tx"/>
-                    </a:ext>
-                  </a:extLst>
-                </a:hlinkClick>
-              </a:rPr>
-              <a:t>live demo</a:t>
             </a:r>
             <a:endParaRPr lang="en-US" sz="1400" dirty="0"/>
           </a:p>
@@ -2539,67 +2504,7 @@
       </p:sp>
       <p:sp>
         <p:nvSpPr>
-          <p:cNvPr id="7" name="Text 5"/>
-          <p:cNvSpPr/>
-          <p:nvPr/>
-        </p:nvSpPr>
-        <p:spPr>
-          <a:xfrm>
-            <a:off x="548640" y="5349240"/>
-            <a:ext cx="11064240" cy="457200"/>
-          </a:xfrm>
-          <a:prstGeom prst="rect">
-            <a:avLst/>
-          </a:prstGeom>
-          <a:noFill/>
-          <a:ln/>
-        </p:spPr>
-        <p:txBody>
-          <a:bodyPr wrap="square" rtlCol="0" anchor="ctr"/>
-          <a:lstStyle/>
-          <a:p>
-            <a:pPr indent="0" marL="0">
-              <a:buNone/>
-            </a:pPr>
-            <a:r>
-              <a:rPr lang="en-US" sz="1600" dirty="0">
-                <a:solidFill>
-                  <a:srgbClr val="C7E7EA"/>
-                </a:solidFill>
-                <a:latin typeface="Calibri" pitchFamily="34" charset="0"/>
-                <a:ea typeface="Calibri" pitchFamily="34" charset="-122"/>
-                <a:cs typeface="Calibri" pitchFamily="34" charset="-120"/>
-              </a:rPr>
-              <a:t>Read the brief: </a:t>
-            </a:r>
-            <a:pPr indent="0" marL="0">
-              <a:buNone/>
-            </a:pPr>
-            <a:r>
-              <a:rPr lang="en-US" sz="1600" b="1" u="sng" dirty="0">
-                <a:solidFill>
-                  <a:srgbClr val="FFFFFF"/>
-                </a:solidFill>
-                <a:latin typeface="Calibri" pitchFamily="34" charset="0"/>
-                <a:ea typeface="Calibri" pitchFamily="34" charset="-122"/>
-                <a:cs typeface="Calibri" pitchFamily="34" charset="-120"/>
-                <a:hlinkClick r:id="rId1" invalidUrl="" action="" tgtFrame="" tooltip="SUPERAGENT.md" history="1" highlightClick="0" endSnd="0">
-                  <a:extLst>
-                    <a:ext uri="{A12FA001-AC4F-418D-AE19-62706E023703}">
-                      <ahyp:hlinkClr xmlns:ahyp="http://schemas.microsoft.com/office/drawing/2018/hyperlinkcolor" val="tx"/>
-                    </a:ext>
-                  </a:extLst>
-                </a:hlinkClick>
-              </a:rPr>
-              <a:t>SUPERAGENT.md</a:t>
-            </a:r>
-            <a:endParaRPr lang="en-US" sz="1600" dirty="0"/>
-          </a:p>
-        </p:txBody>
-      </p:sp>
-      <p:sp>
-        <p:nvSpPr>
-          <p:cNvPr id="8" name="Shape 6"/>
+          <p:cNvPr id="7" name="Shape 5"/>
           <p:cNvSpPr/>
           <p:nvPr/>
         </p:nvSpPr>
@@ -2619,7 +2524,7 @@
       </p:sp>
       <p:sp>
         <p:nvSpPr>
-          <p:cNvPr id="9" name="Text 7"/>
+          <p:cNvPr id="8" name="Text 6"/>
           <p:cNvSpPr/>
           <p:nvPr/>
         </p:nvSpPr>
@@ -3016,7 +2921,7 @@
                 <a:ea typeface="Calibri" pitchFamily="34" charset="-122"/>
                 <a:cs typeface="Calibri" pitchFamily="34" charset="-120"/>
               </a:rPr>
-              <a:t>ISO/IEC 23894</a:t>
+              <a:t>ISO/IEC 27001</a:t>
             </a:r>
             <a:endParaRPr lang="en-US" sz="1100" dirty="0"/>
           </a:p>
@@ -3144,7 +3049,7 @@
                 <a:ea typeface="Calibri" pitchFamily="34" charset="-122"/>
                 <a:cs typeface="Calibri" pitchFamily="34" charset="-120"/>
               </a:rPr>
-              <a:t>GDPR Art. 22/35</a:t>
+              <a:t>GDPR</a:t>
             </a:r>
             <a:endParaRPr lang="en-US" sz="1100" dirty="0"/>
           </a:p>
@@ -3208,7 +3113,7 @@
                 <a:ea typeface="Calibri" pitchFamily="34" charset="-122"/>
                 <a:cs typeface="Calibri" pitchFamily="34" charset="-120"/>
               </a:rPr>
-              <a:t>SOC 2 TSC</a:t>
+              <a:t>SOC 2</a:t>
             </a:r>
             <a:endParaRPr lang="en-US" sz="1100" dirty="0"/>
           </a:p>
@@ -3272,7 +3177,7 @@
                 <a:ea typeface="Calibri" pitchFamily="34" charset="-122"/>
                 <a:cs typeface="Calibri" pitchFamily="34" charset="-120"/>
               </a:rPr>
-              <a:t>AIDA (Canada)</a:t>
+              <a:t>CCPA</a:t>
             </a:r>
             <a:endParaRPr lang="en-US" sz="1100" dirty="0"/>
           </a:p>
@@ -3336,7 +3241,7 @@
                 <a:ea typeface="Calibri" pitchFamily="34" charset="-122"/>
                 <a:cs typeface="Calibri" pitchFamily="34" charset="-120"/>
               </a:rPr>
-              <a:t>OECD AI Principles</a:t>
+              <a:t>OWASP LLM Top 10</a:t>
             </a:r>
             <a:endParaRPr lang="en-US" sz="1100" dirty="0"/>
           </a:p>
@@ -3400,7 +3305,7 @@
                 <a:ea typeface="Calibri" pitchFamily="34" charset="-122"/>
                 <a:cs typeface="Calibri" pitchFamily="34" charset="-120"/>
               </a:rPr>
-              <a:t>IEEE 7000-2021</a:t>
+              <a:t>MITRE ATLAS</a:t>
             </a:r>
             <a:endParaRPr lang="en-US" sz="1100" dirty="0"/>
           </a:p>
@@ -3464,7 +3369,7 @@
                 <a:ea typeface="Calibri" pitchFamily="34" charset="-122"/>
                 <a:cs typeface="Calibri" pitchFamily="34" charset="-120"/>
               </a:rPr>
-              <a:t>Brazil PL 2338</a:t>
+              <a:t>PCI DSS</a:t>
             </a:r>
             <a:endParaRPr lang="en-US" sz="1100" dirty="0"/>
           </a:p>
@@ -3528,7 +3433,7 @@
                 <a:ea typeface="Calibri" pitchFamily="34" charset="-122"/>
                 <a:cs typeface="Calibri" pitchFamily="34" charset="-120"/>
               </a:rPr>
-              <a:t>Korea AI Basic Act</a:t>
+              <a:t>FedRAMP</a:t>
             </a:r>
             <a:endParaRPr lang="en-US" sz="1100" dirty="0"/>
           </a:p>
@@ -3656,7 +3561,7 @@
                 <a:ea typeface="Calibri" pitchFamily="34" charset="-122"/>
                 <a:cs typeface="Calibri" pitchFamily="34" charset="-120"/>
               </a:rPr>
-              <a:t>Colorado SB24-205</a:t>
+              <a:t>Colorado AI Act</a:t>
             </a:r>
             <a:endParaRPr lang="en-US" sz="1100" dirty="0"/>
           </a:p>
@@ -3720,7 +3625,7 @@
                 <a:ea typeface="Calibri" pitchFamily="34" charset="-122"/>
                 <a:cs typeface="Calibri" pitchFamily="34" charset="-120"/>
               </a:rPr>
-              <a:t>California SB-53</a:t>
+              <a:t>California AB-2013</a:t>
             </a:r>
             <a:endParaRPr lang="en-US" sz="1100" dirty="0"/>
           </a:p>
@@ -3848,7 +3753,7 @@
                 <a:ea typeface="Calibri" pitchFamily="34" charset="-122"/>
                 <a:cs typeface="Calibri" pitchFamily="34" charset="-120"/>
               </a:rPr>
-              <a:t>UK AI WP</a:t>
+              <a:t>OECD AI Principles</a:t>
             </a:r>
             <a:endParaRPr lang="en-US" sz="1100" dirty="0"/>
           </a:p>
@@ -3912,7 +3817,7 @@
                 <a:ea typeface="Calibri" pitchFamily="34" charset="-122"/>
                 <a:cs typeface="Calibri" pitchFamily="34" charset="-120"/>
               </a:rPr>
-              <a:t>UN GA A/78/L.49</a:t>
+              <a:t>G7 Hiroshima</a:t>
             </a:r>
             <a:endParaRPr lang="en-US" sz="1100" dirty="0"/>
           </a:p>
@@ -3976,7 +3881,7 @@
                 <a:ea typeface="Calibri" pitchFamily="34" charset="-122"/>
                 <a:cs typeface="Calibri" pitchFamily="34" charset="-120"/>
               </a:rPr>
-              <a:t>Singapore GenAI</a:t>
+              <a:t>UNESCO Ethics</a:t>
             </a:r>
             <a:endParaRPr lang="en-US" sz="1100" dirty="0"/>
           </a:p>
@@ -4040,7 +3945,7 @@
                 <a:ea typeface="Calibri" pitchFamily="34" charset="-122"/>
                 <a:cs typeface="Calibri" pitchFamily="34" charset="-120"/>
               </a:rPr>
-              <a:t>Australia VAISS</a:t>
+              <a:t>Singapore AI</a:t>
             </a:r>
             <a:endParaRPr lang="en-US" sz="1100" dirty="0"/>
           </a:p>
@@ -4104,7 +4009,7 @@
                 <a:ea typeface="Calibri" pitchFamily="34" charset="-122"/>
                 <a:cs typeface="Calibri" pitchFamily="34" charset="-120"/>
               </a:rPr>
-              <a:t>China Interim</a:t>
+              <a:t>UK AI Safety</a:t>
             </a:r>
             <a:endParaRPr lang="en-US" sz="1100" dirty="0"/>
           </a:p>
@@ -4168,7 +4073,7 @@
                 <a:ea typeface="Calibri" pitchFamily="34" charset="-122"/>
                 <a:cs typeface="Calibri" pitchFamily="34" charset="-120"/>
               </a:rPr>
-              <a:t>India DPDP</a:t>
+              <a:t>Canada AIDA</a:t>
             </a:r>
             <a:endParaRPr lang="en-US" sz="1100" dirty="0"/>
           </a:p>
@@ -4232,7 +4137,7 @@
                 <a:ea typeface="Calibri" pitchFamily="34" charset="-122"/>
                 <a:cs typeface="Calibri" pitchFamily="34" charset="-120"/>
               </a:rPr>
-              <a:t>US AI Bill of Rights</a:t>
+              <a:t>ANSI/UL 4600</a:t>
             </a:r>
             <a:endParaRPr lang="en-US" sz="1100" dirty="0"/>
           </a:p>
@@ -4310,66 +4215,6 @@
         </p:nvSpPr>
         <p:spPr>
           <a:xfrm>
-            <a:off x="548640" y="5989320"/>
-            <a:ext cx="11064240" cy="274320"/>
-          </a:xfrm>
-          <a:prstGeom prst="rect">
-            <a:avLst/>
-          </a:prstGeom>
-          <a:noFill/>
-          <a:ln/>
-        </p:spPr>
-        <p:txBody>
-          <a:bodyPr wrap="square" rtlCol="0" anchor="ctr"/>
-          <a:lstStyle/>
-          <a:p>
-            <a:pPr indent="0" marL="0">
-              <a:buNone/>
-            </a:pPr>
-            <a:r>
-              <a:rPr lang="en-US" sz="1100" dirty="0">
-                <a:solidFill>
-                  <a:srgbClr val="01696F"/>
-                </a:solidFill>
-                <a:latin typeface="Calibri" pitchFamily="34" charset="0"/>
-                <a:ea typeface="Calibri" pitchFamily="34" charset="-122"/>
-                <a:cs typeface="Calibri" pitchFamily="34" charset="-120"/>
-              </a:rPr>
-              <a:t>Browse all 23: </a:t>
-            </a:r>
-            <a:pPr indent="0" marL="0">
-              <a:buNone/>
-            </a:pPr>
-            <a:r>
-              <a:rPr lang="en-US" sz="1100" u="sng" dirty="0">
-                <a:solidFill>
-                  <a:srgbClr val="01696F"/>
-                </a:solidFill>
-                <a:latin typeface="Calibri" pitchFamily="34" charset="0"/>
-                <a:ea typeface="Calibri" pitchFamily="34" charset="-122"/>
-                <a:cs typeface="Calibri" pitchFamily="34" charset="-120"/>
-                <a:hlinkClick r:id="rId1" invalidUrl="" action="" tgtFrame="" tooltip="Frameworks folder" history="1" highlightClick="0" endSnd="0">
-                  <a:extLst>
-                    <a:ext uri="{A12FA001-AC4F-418D-AE19-62706E023703}">
-                      <ahyp:hlinkClr xmlns:ahyp="http://schemas.microsoft.com/office/drawing/2018/hyperlinkcolor" val="tx"/>
-                    </a:ext>
-                  </a:extLst>
-                </a:hlinkClick>
-              </a:rPr>
-              <a:t>github.com/bobrapp/aigovops-beacon/tree/main/frameworks</a:t>
-            </a:r>
-            <a:endParaRPr lang="en-US" sz="1100" dirty="0"/>
-          </a:p>
-        </p:txBody>
-      </p:sp>
-      <p:sp>
-        <p:nvSpPr>
-          <p:cNvPr id="53" name="Text 51"/>
-          <p:cNvSpPr/>
-          <p:nvPr/>
-        </p:nvSpPr>
-        <p:spPr>
-          <a:xfrm>
             <a:off x="457200" y="6537960"/>
             <a:ext cx="3657600" cy="228600"/>
           </a:xfrm>
@@ -4395,7 +4240,7 @@
                 <a:ea typeface="Calibri" pitchFamily="34" charset="-122"/>
                 <a:cs typeface="Calibri" pitchFamily="34" charset="-120"/>
               </a:rPr>
-              <a:t>Beacon · v2.5 · Small</a:t>
+              <a:t>Beacon · v2.3</a:t>
             </a:r>
             <a:endParaRPr lang="en-US" sz="900" dirty="0"/>
           </a:p>
@@ -4403,7 +4248,7 @@
       </p:sp>
       <p:sp>
         <p:nvSpPr>
-          <p:cNvPr id="54" name="Text 52"/>
+          <p:cNvPr id="53" name="Text 51"/>
           <p:cNvSpPr/>
           <p:nvPr/>
         </p:nvSpPr>
@@ -4611,7 +4456,7 @@
                 <a:ea typeface="Courier New" pitchFamily="34" charset="-122"/>
                 <a:cs typeface="Courier New" pitchFamily="34" charset="-120"/>
               </a:rPr>
-              <a:t>$  git clone https://github.com/bobrapp/aigovops-beacon</a:t>
+              <a:t>$  git clone https://github.com/aigovops-foundation/aigovops-beacon</a:t>
             </a:r>
             <a:endParaRPr lang="en-US" sz="1600" dirty="0"/>
           </a:p>
@@ -4731,20 +4576,13 @@
               <a:buNone/>
             </a:pPr>
             <a:r>
-              <a:rPr lang="en-US" sz="1300" b="1" u="sng" dirty="0">
+              <a:rPr lang="en-US" sz="1300" b="1" dirty="0">
                 <a:solidFill>
                   <a:srgbClr val="01696F"/>
                 </a:solidFill>
                 <a:latin typeface="Courier New" pitchFamily="34" charset="0"/>
                 <a:ea typeface="Courier New" pitchFamily="34" charset="-122"/>
                 <a:cs typeface="Courier New" pitchFamily="34" charset="-120"/>
-                <a:hlinkClick r:id="rId1" invalidUrl="" action="" tgtFrame="" tooltip="" history="1" highlightClick="0" endSnd="0">
-                  <a:extLst>
-                    <a:ext uri="{A12FA001-AC4F-418D-AE19-62706E023703}">
-                      <ahyp:hlinkClr xmlns:ahyp="http://schemas.microsoft.com/office/drawing/2018/hyperlinkcolor" val="tx"/>
-                    </a:ext>
-                  </a:extLst>
-                </a:hlinkClick>
               </a:rPr>
               <a:t>DEMOS.md</a:t>
             </a:r>
@@ -4816,20 +4654,13 @@
               <a:buNone/>
             </a:pPr>
             <a:r>
-              <a:rPr lang="en-US" sz="1300" b="1" u="sng" dirty="0">
+              <a:rPr lang="en-US" sz="1300" b="1" dirty="0">
                 <a:solidFill>
                   <a:srgbClr val="01696F"/>
                 </a:solidFill>
                 <a:latin typeface="Courier New" pitchFamily="34" charset="0"/>
                 <a:ea typeface="Courier New" pitchFamily="34" charset="-122"/>
                 <a:cs typeface="Courier New" pitchFamily="34" charset="-120"/>
-                <a:hlinkClick r:id="rId2" invalidUrl="" action="" tgtFrame="" tooltip="" history="1" highlightClick="0" endSnd="0">
-                  <a:extLst>
-                    <a:ext uri="{A12FA001-AC4F-418D-AE19-62706E023703}">
-                      <ahyp:hlinkClr xmlns:ahyp="http://schemas.microsoft.com/office/drawing/2018/hyperlinkcolor" val="tx"/>
-                    </a:ext>
-                  </a:extLst>
-                </a:hlinkClick>
               </a:rPr>
               <a:t>SUPERAGENT.md</a:t>
             </a:r>
@@ -4901,20 +4732,13 @@
               <a:buNone/>
             </a:pPr>
             <a:r>
-              <a:rPr lang="en-US" sz="1300" b="1" u="sng" dirty="0">
+              <a:rPr lang="en-US" sz="1300" b="1" dirty="0">
                 <a:solidFill>
                   <a:srgbClr val="01696F"/>
                 </a:solidFill>
                 <a:latin typeface="Courier New" pitchFamily="34" charset="0"/>
                 <a:ea typeface="Courier New" pitchFamily="34" charset="-122"/>
                 <a:cs typeface="Courier New" pitchFamily="34" charset="-120"/>
-                <a:hlinkClick r:id="rId3" invalidUrl="" action="" tgtFrame="" tooltip="" history="1" highlightClick="0" endSnd="0">
-                  <a:extLst>
-                    <a:ext uri="{A12FA001-AC4F-418D-AE19-62706E023703}">
-                      <ahyp:hlinkClr xmlns:ahyp="http://schemas.microsoft.com/office/drawing/2018/hyperlinkcolor" val="tx"/>
-                    </a:ext>
-                  </a:extLst>
-                </a:hlinkClick>
               </a:rPr>
               <a:t>walkthrough/</a:t>
             </a:r>
@@ -4994,7 +4818,7 @@
                 <a:ea typeface="Calibri" pitchFamily="34" charset="-122"/>
                 <a:cs typeface="Calibri" pitchFamily="34" charset="-120"/>
               </a:rPr>
-              <a:t>Beacon · v2.5 · Small</a:t>
+              <a:t>Beacon · v2.3</a:t>
             </a:r>
             <a:endParaRPr lang="en-US" sz="900" dirty="0"/>
           </a:p>
@@ -5331,7 +5155,7 @@
                   </a:extLst>
                 </a:hlinkClick>
               </a:rPr>
-              <a:t>github.com/bobrapp/aigovops-beacon</a:t>
+              <a:t>github.com/aigovops-foundation/aigovops-beacon</a:t>
             </a:r>
             <a:endParaRPr lang="en-US" sz="1500" dirty="0"/>
           </a:p>
@@ -5636,7 +5460,7 @@
                 <a:ea typeface="Calibri" pitchFamily="34" charset="-122"/>
                 <a:cs typeface="Calibri" pitchFamily="34" charset="-120"/>
               </a:rPr>
-              <a:t>Beacon · v2.5 · Small</a:t>
+              <a:t>Beacon · v2.3</a:t>
             </a:r>
             <a:endParaRPr lang="en-US" sz="900" dirty="0"/>
           </a:p>
@@ -5838,24 +5662,24 @@
         </p:nvSpPr>
         <p:spPr>
           <a:xfrm>
-            <a:off x="548640" y="4617720"/>
-            <a:ext cx="11064240" cy="457200"/>
-          </a:xfrm>
-          <a:prstGeom prst="rect">
-            <a:avLst/>
-          </a:prstGeom>
-          <a:noFill/>
-          <a:ln/>
-        </p:spPr>
-        <p:txBody>
-          <a:bodyPr wrap="square" rtlCol="0" anchor="ctr"/>
-          <a:lstStyle/>
-          <a:p>
-            <a:pPr indent="0" marL="0">
-              <a:buNone/>
-            </a:pPr>
-            <a:r>
-              <a:rPr lang="en-US" sz="2000" dirty="0">
+            <a:off x="548640" y="4754880"/>
+            <a:ext cx="11064240" cy="502920"/>
+          </a:xfrm>
+          <a:prstGeom prst="rect">
+            <a:avLst/>
+          </a:prstGeom>
+          <a:noFill/>
+          <a:ln/>
+        </p:spPr>
+        <p:txBody>
+          <a:bodyPr wrap="square" rtlCol="0" anchor="ctr"/>
+          <a:lstStyle/>
+          <a:p>
+            <a:pPr indent="0" marL="0">
+              <a:buNone/>
+            </a:pPr>
+            <a:r>
+              <a:rPr lang="en-US" sz="2200" dirty="0">
                 <a:solidFill>
                   <a:srgbClr val="01696F"/>
                 </a:solidFill>
@@ -5869,7 +5693,7 @@
               <a:buNone/>
             </a:pPr>
             <a:r>
-              <a:rPr lang="en-US" sz="2000" b="1" u="sng" dirty="0">
+              <a:rPr lang="en-US" sz="2200" b="1" u="sng" dirty="0">
                 <a:solidFill>
                   <a:srgbClr val="FFFFFF"/>
                 </a:solidFill>
@@ -5884,9 +5708,9 @@
                   </a:extLst>
                 </a:hlinkClick>
               </a:rPr>
-              <a:t>github.com/bobrapp/aigovops-beacon</a:t>
-            </a:r>
-            <a:endParaRPr lang="en-US" sz="2000" dirty="0"/>
+              <a:t>github.com/aigovops-foundation/aigovops-beacon</a:t>
+            </a:r>
+            <a:endParaRPr lang="en-US" sz="2200" dirty="0"/>
           </a:p>
         </p:txBody>
       </p:sp>
@@ -5898,24 +5722,24 @@
         </p:nvSpPr>
         <p:spPr>
           <a:xfrm>
-            <a:off x="548640" y="5120640"/>
-            <a:ext cx="11064240" cy="457200"/>
-          </a:xfrm>
-          <a:prstGeom prst="rect">
-            <a:avLst/>
-          </a:prstGeom>
-          <a:noFill/>
-          <a:ln/>
-        </p:spPr>
-        <p:txBody>
-          <a:bodyPr wrap="square" rtlCol="0" anchor="ctr"/>
-          <a:lstStyle/>
-          <a:p>
-            <a:pPr indent="0" marL="0">
-              <a:buNone/>
-            </a:pPr>
-            <a:r>
-              <a:rPr lang="en-US" sz="2000" dirty="0">
+            <a:off x="548640" y="5349240"/>
+            <a:ext cx="11064240" cy="502920"/>
+          </a:xfrm>
+          <a:prstGeom prst="rect">
+            <a:avLst/>
+          </a:prstGeom>
+          <a:noFill/>
+          <a:ln/>
+        </p:spPr>
+        <p:txBody>
+          <a:bodyPr wrap="square" rtlCol="0" anchor="ctr"/>
+          <a:lstStyle/>
+          <a:p>
+            <a:pPr indent="0" marL="0">
+              <a:buNone/>
+            </a:pPr>
+            <a:r>
+              <a:rPr lang="en-US" sz="2200" dirty="0">
                 <a:solidFill>
                   <a:srgbClr val="01696F"/>
                 </a:solidFill>
@@ -5929,7 +5753,7 @@
               <a:buNone/>
             </a:pPr>
             <a:r>
-              <a:rPr lang="en-US" sz="2000" b="1" u="sng" dirty="0">
+              <a:rPr lang="en-US" sz="2200" b="1" u="sng" dirty="0">
                 <a:solidFill>
                   <a:srgbClr val="FFFFFF"/>
                 </a:solidFill>
@@ -5946,87 +5770,13 @@
               </a:rPr>
               <a:t>aigovopsfoundation.org</a:t>
             </a:r>
-            <a:endParaRPr lang="en-US" sz="2000" dirty="0"/>
-          </a:p>
-        </p:txBody>
-      </p:sp>
-      <p:sp>
-        <p:nvSpPr>
-          <p:cNvPr id="7" name="Text 5"/>
-          <p:cNvSpPr/>
-          <p:nvPr/>
-        </p:nvSpPr>
-        <p:spPr>
-          <a:xfrm>
-            <a:off x="548640" y="5623560"/>
-            <a:ext cx="11064240" cy="457200"/>
-          </a:xfrm>
-          <a:prstGeom prst="rect">
-            <a:avLst/>
-          </a:prstGeom>
-          <a:noFill/>
-          <a:ln/>
-        </p:spPr>
-        <p:txBody>
-          <a:bodyPr wrap="square" rtlCol="0" anchor="ctr"/>
-          <a:lstStyle/>
-          <a:p>
-            <a:pPr indent="0" marL="0">
-              <a:buNone/>
-            </a:pPr>
-            <a:r>
-              <a:rPr lang="en-US" sz="1800" dirty="0">
-                <a:solidFill>
-                  <a:srgbClr val="01696F"/>
-                </a:solidFill>
-                <a:latin typeface="Calibri" pitchFamily="34" charset="0"/>
-                <a:ea typeface="Calibri" pitchFamily="34" charset="-122"/>
-                <a:cs typeface="Calibri" pitchFamily="34" charset="-120"/>
-              </a:rPr>
-              <a:t>→  </a:t>
-            </a:r>
-            <a:pPr indent="0" marL="0">
-              <a:buNone/>
-            </a:pPr>
-            <a:r>
-              <a:rPr lang="en-US" sz="1800" b="1" u="sng" dirty="0">
-                <a:solidFill>
-                  <a:srgbClr val="FFFFFF"/>
-                </a:solidFill>
-                <a:latin typeface="Calibri" pitchFamily="34" charset="0"/>
-                <a:ea typeface="Calibri" pitchFamily="34" charset="-122"/>
-                <a:cs typeface="Calibri" pitchFamily="34" charset="-120"/>
-                <a:hlinkClick r:id="rId3" invalidUrl="" action="" tgtFrame="" tooltip="" history="1" highlightClick="0" endSnd="0">
-                  <a:extLst>
-                    <a:ext uri="{A12FA001-AC4F-418D-AE19-62706E023703}">
-                      <ahyp:hlinkClr xmlns:ahyp="http://schemas.microsoft.com/office/drawing/2018/hyperlinkcolor" val="tx"/>
-                    </a:ext>
-                  </a:extLst>
-                </a:hlinkClick>
-              </a:rPr>
-              <a:t>aigovops-fact-check.md  </a:t>
-            </a:r>
-            <a:pPr indent="0" marL="0">
-              <a:buNone/>
-            </a:pPr>
-            <a:r>
-              <a:rPr lang="en-US" sz="1800" dirty="0">
-                <a:solidFill>
-                  <a:srgbClr val="8FB7BB"/>
-                </a:solidFill>
-                <a:latin typeface="Calibri" pitchFamily="34" charset="0"/>
-                <a:ea typeface="Calibri" pitchFamily="34" charset="-122"/>
-                <a:cs typeface="Calibri" pitchFamily="34" charset="-120"/>
-              </a:rPr>
-              <a:t>— every claim in the repo, classified and sourced.</a:t>
-            </a:r>
-            <a:endParaRPr lang="en-US" sz="1800" dirty="0"/>
-          </a:p>
-        </p:txBody>
-      </p:sp>
-      <p:sp>
-        <p:nvSpPr>
-          <p:cNvPr id="8" name="Shape 6"/>
+            <a:endParaRPr lang="en-US" sz="2200" dirty="0"/>
+          </a:p>
+        </p:txBody>
+      </p:sp>
+      <p:sp>
+        <p:nvSpPr>
+          <p:cNvPr id="7" name="Shape 5"/>
           <p:cNvSpPr/>
           <p:nvPr/>
         </p:nvSpPr>
@@ -6046,7 +5796,7 @@
       </p:sp>
       <p:sp>
         <p:nvSpPr>
-          <p:cNvPr id="9" name="Text 7"/>
+          <p:cNvPr id="8" name="Text 6"/>
           <p:cNvSpPr/>
           <p:nvPr/>
         </p:nvSpPr>
@@ -6538,7 +6288,7 @@
                 <a:ea typeface="Calibri" pitchFamily="34" charset="-122"/>
                 <a:cs typeface="Calibri" pitchFamily="34" charset="-120"/>
               </a:rPr>
-              <a:t>Beacon · v2.5 · Small</a:t>
+              <a:t>Beacon · v2.3</a:t>
             </a:r>
             <a:endParaRPr lang="en-US" sz="900" dirty="0"/>
           </a:p>
@@ -6804,7 +6554,7 @@
                 <a:ea typeface="Calibri" pitchFamily="34" charset="-122"/>
                 <a:cs typeface="Calibri" pitchFamily="34" charset="-120"/>
               </a:rPr>
-              <a:t>Beacon · v2.5 · Small</a:t>
+              <a:t>Beacon · v2.3</a:t>
             </a:r>
             <a:endParaRPr lang="en-US" sz="900" dirty="0"/>
           </a:p>
@@ -7418,7 +7168,7 @@
                 <a:ea typeface="Calibri" pitchFamily="34" charset="-122"/>
                 <a:cs typeface="Calibri" pitchFamily="34" charset="-120"/>
               </a:rPr>
-              <a:t>Beacon · v2.5 · Small</a:t>
+              <a:t>Beacon · v2.3</a:t>
             </a:r>
             <a:endParaRPr lang="en-US" sz="900" dirty="0"/>
           </a:p>
@@ -7581,8 +7331,8 @@
         </p:nvSpPr>
         <p:spPr>
           <a:xfrm>
-            <a:off x="548640" y="2011680"/>
-            <a:ext cx="5577840" cy="1188720"/>
+            <a:off x="548640" y="2103120"/>
+            <a:ext cx="5577840" cy="1325880"/>
           </a:xfrm>
           <a:prstGeom prst="rect">
             <a:avLst/>
@@ -7606,24 +7356,24 @@
         </p:nvSpPr>
         <p:spPr>
           <a:xfrm>
-            <a:off x="822960" y="2148840"/>
-            <a:ext cx="5029200" cy="411480"/>
-          </a:xfrm>
-          <a:prstGeom prst="rect">
-            <a:avLst/>
-          </a:prstGeom>
-          <a:noFill/>
-          <a:ln/>
-        </p:spPr>
-        <p:txBody>
-          <a:bodyPr wrap="square" rtlCol="0" anchor="ctr"/>
-          <a:lstStyle/>
-          <a:p>
-            <a:pPr indent="0" marL="0">
-              <a:buNone/>
-            </a:pPr>
-            <a:r>
-              <a:rPr lang="en-US" sz="1700" b="1" dirty="0">
+            <a:off x="822960" y="2267712"/>
+            <a:ext cx="5029200" cy="457200"/>
+          </a:xfrm>
+          <a:prstGeom prst="rect">
+            <a:avLst/>
+          </a:prstGeom>
+          <a:noFill/>
+          <a:ln/>
+        </p:spPr>
+        <p:txBody>
+          <a:bodyPr wrap="square" rtlCol="0" anchor="ctr"/>
+          <a:lstStyle/>
+          <a:p>
+            <a:pPr indent="0" marL="0">
+              <a:buNone/>
+            </a:pPr>
+            <a:r>
+              <a:rPr lang="en-US" sz="1800" b="1" dirty="0">
                 <a:solidFill>
                   <a:srgbClr val="01696F"/>
                 </a:solidFill>
@@ -7633,7 +7383,7 @@
               </a:rPr>
               <a:t>record_decision</a:t>
             </a:r>
-            <a:endParaRPr lang="en-US" sz="1700" dirty="0"/>
+            <a:endParaRPr lang="en-US" sz="1800" dirty="0"/>
           </a:p>
         </p:txBody>
       </p:sp>
@@ -7645,24 +7395,24 @@
         </p:nvSpPr>
         <p:spPr>
           <a:xfrm>
-            <a:off x="822960" y="2606040"/>
-            <a:ext cx="5029200" cy="502920"/>
-          </a:xfrm>
-          <a:prstGeom prst="rect">
-            <a:avLst/>
-          </a:prstGeom>
-          <a:noFill/>
-          <a:ln/>
-        </p:spPr>
-        <p:txBody>
-          <a:bodyPr wrap="square" rtlCol="0" anchor="ctr"/>
-          <a:lstStyle/>
-          <a:p>
-            <a:pPr indent="0" marL="0">
-              <a:buNone/>
-            </a:pPr>
-            <a:r>
-              <a:rPr lang="en-US" sz="1200" dirty="0">
+            <a:off x="822960" y="2788920"/>
+            <a:ext cx="5029200" cy="594360"/>
+          </a:xfrm>
+          <a:prstGeom prst="rect">
+            <a:avLst/>
+          </a:prstGeom>
+          <a:noFill/>
+          <a:ln/>
+        </p:spPr>
+        <p:txBody>
+          <a:bodyPr wrap="square" rtlCol="0" anchor="ctr"/>
+          <a:lstStyle/>
+          <a:p>
+            <a:pPr indent="0" marL="0">
+              <a:buNone/>
+            </a:pPr>
+            <a:r>
+              <a:rPr lang="en-US" sz="1300" dirty="0">
                 <a:solidFill>
                   <a:srgbClr val="28251D"/>
                 </a:solidFill>
@@ -7672,7 +7422,7 @@
               </a:rPr>
               <a:t>Sign a decision. Returns a receipt.</a:t>
             </a:r>
-            <a:endParaRPr lang="en-US" sz="1200" dirty="0"/>
+            <a:endParaRPr lang="en-US" sz="1300" dirty="0"/>
           </a:p>
         </p:txBody>
       </p:sp>
@@ -7684,8 +7434,8 @@
         </p:nvSpPr>
         <p:spPr>
           <a:xfrm>
-            <a:off x="6263640" y="2011680"/>
-            <a:ext cx="5577840" cy="1188720"/>
+            <a:off x="6263640" y="2103120"/>
+            <a:ext cx="5577840" cy="1325880"/>
           </a:xfrm>
           <a:prstGeom prst="rect">
             <a:avLst/>
@@ -7709,24 +7459,24 @@
         </p:nvSpPr>
         <p:spPr>
           <a:xfrm>
-            <a:off x="6537960" y="2148840"/>
-            <a:ext cx="5029200" cy="411480"/>
-          </a:xfrm>
-          <a:prstGeom prst="rect">
-            <a:avLst/>
-          </a:prstGeom>
-          <a:noFill/>
-          <a:ln/>
-        </p:spPr>
-        <p:txBody>
-          <a:bodyPr wrap="square" rtlCol="0" anchor="ctr"/>
-          <a:lstStyle/>
-          <a:p>
-            <a:pPr indent="0" marL="0">
-              <a:buNone/>
-            </a:pPr>
-            <a:r>
-              <a:rPr lang="en-US" sz="1700" b="1" dirty="0">
+            <a:off x="6537960" y="2267712"/>
+            <a:ext cx="5029200" cy="457200"/>
+          </a:xfrm>
+          <a:prstGeom prst="rect">
+            <a:avLst/>
+          </a:prstGeom>
+          <a:noFill/>
+          <a:ln/>
+        </p:spPr>
+        <p:txBody>
+          <a:bodyPr wrap="square" rtlCol="0" anchor="ctr"/>
+          <a:lstStyle/>
+          <a:p>
+            <a:pPr indent="0" marL="0">
+              <a:buNone/>
+            </a:pPr>
+            <a:r>
+              <a:rPr lang="en-US" sz="1800" b="1" dirty="0">
                 <a:solidFill>
                   <a:srgbClr val="01696F"/>
                 </a:solidFill>
@@ -7736,7 +7486,7 @@
               </a:rPr>
               <a:t>verify_receipt</a:t>
             </a:r>
-            <a:endParaRPr lang="en-US" sz="1700" dirty="0"/>
+            <a:endParaRPr lang="en-US" sz="1800" dirty="0"/>
           </a:p>
         </p:txBody>
       </p:sp>
@@ -7748,24 +7498,24 @@
         </p:nvSpPr>
         <p:spPr>
           <a:xfrm>
-            <a:off x="6537960" y="2606040"/>
-            <a:ext cx="5029200" cy="502920"/>
-          </a:xfrm>
-          <a:prstGeom prst="rect">
-            <a:avLst/>
-          </a:prstGeom>
-          <a:noFill/>
-          <a:ln/>
-        </p:spPr>
-        <p:txBody>
-          <a:bodyPr wrap="square" rtlCol="0" anchor="ctr"/>
-          <a:lstStyle/>
-          <a:p>
-            <a:pPr indent="0" marL="0">
-              <a:buNone/>
-            </a:pPr>
-            <a:r>
-              <a:rPr lang="en-US" sz="1200" dirty="0">
+            <a:off x="6537960" y="2788920"/>
+            <a:ext cx="5029200" cy="594360"/>
+          </a:xfrm>
+          <a:prstGeom prst="rect">
+            <a:avLst/>
+          </a:prstGeom>
+          <a:noFill/>
+          <a:ln/>
+        </p:spPr>
+        <p:txBody>
+          <a:bodyPr wrap="square" rtlCol="0" anchor="ctr"/>
+          <a:lstStyle/>
+          <a:p>
+            <a:pPr indent="0" marL="0">
+              <a:buNone/>
+            </a:pPr>
+            <a:r>
+              <a:rPr lang="en-US" sz="1300" dirty="0">
                 <a:solidFill>
                   <a:srgbClr val="28251D"/>
                 </a:solidFill>
@@ -7775,7 +7525,7 @@
               </a:rPr>
               <a:t>Re-validate any receipt against its signature.</a:t>
             </a:r>
-            <a:endParaRPr lang="en-US" sz="1200" dirty="0"/>
+            <a:endParaRPr lang="en-US" sz="1300" dirty="0"/>
           </a:p>
         </p:txBody>
       </p:sp>
@@ -7787,8 +7537,8 @@
         </p:nvSpPr>
         <p:spPr>
           <a:xfrm>
-            <a:off x="548640" y="3337560"/>
-            <a:ext cx="5577840" cy="1188720"/>
+            <a:off x="548640" y="3593592"/>
+            <a:ext cx="5577840" cy="1325880"/>
           </a:xfrm>
           <a:prstGeom prst="rect">
             <a:avLst/>
@@ -7812,24 +7562,24 @@
         </p:nvSpPr>
         <p:spPr>
           <a:xfrm>
-            <a:off x="822960" y="3474720"/>
-            <a:ext cx="5029200" cy="411480"/>
-          </a:xfrm>
-          <a:prstGeom prst="rect">
-            <a:avLst/>
-          </a:prstGeom>
-          <a:noFill/>
-          <a:ln/>
-        </p:spPr>
-        <p:txBody>
-          <a:bodyPr wrap="square" rtlCol="0" anchor="ctr"/>
-          <a:lstStyle/>
-          <a:p>
-            <a:pPr indent="0" marL="0">
-              <a:buNone/>
-            </a:pPr>
-            <a:r>
-              <a:rPr lang="en-US" sz="1700" b="1" dirty="0">
+            <a:off x="822960" y="3758184"/>
+            <a:ext cx="5029200" cy="457200"/>
+          </a:xfrm>
+          <a:prstGeom prst="rect">
+            <a:avLst/>
+          </a:prstGeom>
+          <a:noFill/>
+          <a:ln/>
+        </p:spPr>
+        <p:txBody>
+          <a:bodyPr wrap="square" rtlCol="0" anchor="ctr"/>
+          <a:lstStyle/>
+          <a:p>
+            <a:pPr indent="0" marL="0">
+              <a:buNone/>
+            </a:pPr>
+            <a:r>
+              <a:rPr lang="en-US" sz="1800" b="1" dirty="0">
                 <a:solidFill>
                   <a:srgbClr val="01696F"/>
                 </a:solidFill>
@@ -7839,7 +7589,7 @@
               </a:rPr>
               <a:t>query_inventory</a:t>
             </a:r>
-            <a:endParaRPr lang="en-US" sz="1700" dirty="0"/>
+            <a:endParaRPr lang="en-US" sz="1800" dirty="0"/>
           </a:p>
         </p:txBody>
       </p:sp>
@@ -7851,24 +7601,24 @@
         </p:nvSpPr>
         <p:spPr>
           <a:xfrm>
-            <a:off x="822960" y="3931920"/>
-            <a:ext cx="5029200" cy="502920"/>
-          </a:xfrm>
-          <a:prstGeom prst="rect">
-            <a:avLst/>
-          </a:prstGeom>
-          <a:noFill/>
-          <a:ln/>
-        </p:spPr>
-        <p:txBody>
-          <a:bodyPr wrap="square" rtlCol="0" anchor="ctr"/>
-          <a:lstStyle/>
-          <a:p>
-            <a:pPr indent="0" marL="0">
-              <a:buNone/>
-            </a:pPr>
-            <a:r>
-              <a:rPr lang="en-US" sz="1200" dirty="0">
+            <a:off x="822960" y="4279392"/>
+            <a:ext cx="5029200" cy="594360"/>
+          </a:xfrm>
+          <a:prstGeom prst="rect">
+            <a:avLst/>
+          </a:prstGeom>
+          <a:noFill/>
+          <a:ln/>
+        </p:spPr>
+        <p:txBody>
+          <a:bodyPr wrap="square" rtlCol="0" anchor="ctr"/>
+          <a:lstStyle/>
+          <a:p>
+            <a:pPr indent="0" marL="0">
+              <a:buNone/>
+            </a:pPr>
+            <a:r>
+              <a:rPr lang="en-US" sz="1300" dirty="0">
                 <a:solidFill>
                   <a:srgbClr val="28251D"/>
                 </a:solidFill>
@@ -7878,7 +7628,7 @@
               </a:rPr>
               <a:t>Search every model, decision, and dataset on file.</a:t>
             </a:r>
-            <a:endParaRPr lang="en-US" sz="1200" dirty="0"/>
+            <a:endParaRPr lang="en-US" sz="1300" dirty="0"/>
           </a:p>
         </p:txBody>
       </p:sp>
@@ -7890,8 +7640,8 @@
         </p:nvSpPr>
         <p:spPr>
           <a:xfrm>
-            <a:off x="6263640" y="3337560"/>
-            <a:ext cx="5577840" cy="1188720"/>
+            <a:off x="6263640" y="3593592"/>
+            <a:ext cx="5577840" cy="1325880"/>
           </a:xfrm>
           <a:prstGeom prst="rect">
             <a:avLst/>
@@ -7915,24 +7665,24 @@
         </p:nvSpPr>
         <p:spPr>
           <a:xfrm>
-            <a:off x="6537960" y="3474720"/>
-            <a:ext cx="5029200" cy="411480"/>
-          </a:xfrm>
-          <a:prstGeom prst="rect">
-            <a:avLst/>
-          </a:prstGeom>
-          <a:noFill/>
-          <a:ln/>
-        </p:spPr>
-        <p:txBody>
-          <a:bodyPr wrap="square" rtlCol="0" anchor="ctr"/>
-          <a:lstStyle/>
-          <a:p>
-            <a:pPr indent="0" marL="0">
-              <a:buNone/>
-            </a:pPr>
-            <a:r>
-              <a:rPr lang="en-US" sz="1700" b="1" dirty="0">
+            <a:off x="6537960" y="3758184"/>
+            <a:ext cx="5029200" cy="457200"/>
+          </a:xfrm>
+          <a:prstGeom prst="rect">
+            <a:avLst/>
+          </a:prstGeom>
+          <a:noFill/>
+          <a:ln/>
+        </p:spPr>
+        <p:txBody>
+          <a:bodyPr wrap="square" rtlCol="0" anchor="ctr"/>
+          <a:lstStyle/>
+          <a:p>
+            <a:pPr indent="0" marL="0">
+              <a:buNone/>
+            </a:pPr>
+            <a:r>
+              <a:rPr lang="en-US" sz="1800" b="1" dirty="0">
                 <a:solidFill>
                   <a:srgbClr val="01696F"/>
                 </a:solidFill>
@@ -7942,7 +7692,7 @@
               </a:rPr>
               <a:t>score_framework</a:t>
             </a:r>
-            <a:endParaRPr lang="en-US" sz="1700" dirty="0"/>
+            <a:endParaRPr lang="en-US" sz="1800" dirty="0"/>
           </a:p>
         </p:txBody>
       </p:sp>
@@ -7954,24 +7704,24 @@
         </p:nvSpPr>
         <p:spPr>
           <a:xfrm>
-            <a:off x="6537960" y="3931920"/>
-            <a:ext cx="5029200" cy="502920"/>
-          </a:xfrm>
-          <a:prstGeom prst="rect">
-            <a:avLst/>
-          </a:prstGeom>
-          <a:noFill/>
-          <a:ln/>
-        </p:spPr>
-        <p:txBody>
-          <a:bodyPr wrap="square" rtlCol="0" anchor="ctr"/>
-          <a:lstStyle/>
-          <a:p>
-            <a:pPr indent="0" marL="0">
-              <a:buNone/>
-            </a:pPr>
-            <a:r>
-              <a:rPr lang="en-US" sz="1200" dirty="0">
+            <a:off x="6537960" y="4279392"/>
+            <a:ext cx="5029200" cy="594360"/>
+          </a:xfrm>
+          <a:prstGeom prst="rect">
+            <a:avLst/>
+          </a:prstGeom>
+          <a:noFill/>
+          <a:ln/>
+        </p:spPr>
+        <p:txBody>
+          <a:bodyPr wrap="square" rtlCol="0" anchor="ctr"/>
+          <a:lstStyle/>
+          <a:p>
+            <a:pPr indent="0" marL="0">
+              <a:buNone/>
+            </a:pPr>
+            <a:r>
+              <a:rPr lang="en-US" sz="1300" dirty="0">
                 <a:solidFill>
                   <a:srgbClr val="28251D"/>
                 </a:solidFill>
@@ -7981,7 +7731,7 @@
               </a:rPr>
               <a:t>Score posture against NIST, EU AI Act, ISO 42001, HIPAA.</a:t>
             </a:r>
-            <a:endParaRPr lang="en-US" sz="1200" dirty="0"/>
+            <a:endParaRPr lang="en-US" sz="1300" dirty="0"/>
           </a:p>
         </p:txBody>
       </p:sp>
@@ -7993,8 +7743,8 @@
         </p:nvSpPr>
         <p:spPr>
           <a:xfrm>
-            <a:off x="548640" y="4663440"/>
-            <a:ext cx="5577840" cy="1188720"/>
+            <a:off x="548640" y="5084064"/>
+            <a:ext cx="5577840" cy="1325880"/>
           </a:xfrm>
           <a:prstGeom prst="rect">
             <a:avLst/>
@@ -8018,24 +7768,24 @@
         </p:nvSpPr>
         <p:spPr>
           <a:xfrm>
-            <a:off x="822960" y="4800600"/>
-            <a:ext cx="5029200" cy="411480"/>
-          </a:xfrm>
-          <a:prstGeom prst="rect">
-            <a:avLst/>
-          </a:prstGeom>
-          <a:noFill/>
-          <a:ln/>
-        </p:spPr>
-        <p:txBody>
-          <a:bodyPr wrap="square" rtlCol="0" anchor="ctr"/>
-          <a:lstStyle/>
-          <a:p>
-            <a:pPr indent="0" marL="0">
-              <a:buNone/>
-            </a:pPr>
-            <a:r>
-              <a:rPr lang="en-US" sz="1700" b="1" dirty="0">
+            <a:off x="822960" y="5248656"/>
+            <a:ext cx="5029200" cy="457200"/>
+          </a:xfrm>
+          <a:prstGeom prst="rect">
+            <a:avLst/>
+          </a:prstGeom>
+          <a:noFill/>
+          <a:ln/>
+        </p:spPr>
+        <p:txBody>
+          <a:bodyPr wrap="square" rtlCol="0" anchor="ctr"/>
+          <a:lstStyle/>
+          <a:p>
+            <a:pPr indent="0" marL="0">
+              <a:buNone/>
+            </a:pPr>
+            <a:r>
+              <a:rPr lang="en-US" sz="1800" b="1" dirty="0">
                 <a:solidFill>
                   <a:srgbClr val="01696F"/>
                 </a:solidFill>
@@ -8045,7 +7795,7 @@
               </a:rPr>
               <a:t>bundle_for_auditor</a:t>
             </a:r>
-            <a:endParaRPr lang="en-US" sz="1700" dirty="0"/>
+            <a:endParaRPr lang="en-US" sz="1800" dirty="0"/>
           </a:p>
         </p:txBody>
       </p:sp>
@@ -8057,24 +7807,24 @@
         </p:nvSpPr>
         <p:spPr>
           <a:xfrm>
-            <a:off x="822960" y="5257800"/>
-            <a:ext cx="5029200" cy="502920"/>
-          </a:xfrm>
-          <a:prstGeom prst="rect">
-            <a:avLst/>
-          </a:prstGeom>
-          <a:noFill/>
-          <a:ln/>
-        </p:spPr>
-        <p:txBody>
-          <a:bodyPr wrap="square" rtlCol="0" anchor="ctr"/>
-          <a:lstStyle/>
-          <a:p>
-            <a:pPr indent="0" marL="0">
-              <a:buNone/>
-            </a:pPr>
-            <a:r>
-              <a:rPr lang="en-US" sz="1200" dirty="0">
+            <a:off x="822960" y="5769864"/>
+            <a:ext cx="5029200" cy="594360"/>
+          </a:xfrm>
+          <a:prstGeom prst="rect">
+            <a:avLst/>
+          </a:prstGeom>
+          <a:noFill/>
+          <a:ln/>
+        </p:spPr>
+        <p:txBody>
+          <a:bodyPr wrap="square" rtlCol="0" anchor="ctr"/>
+          <a:lstStyle/>
+          <a:p>
+            <a:pPr indent="0" marL="0">
+              <a:buNone/>
+            </a:pPr>
+            <a:r>
+              <a:rPr lang="en-US" sz="1300" dirty="0">
                 <a:solidFill>
                   <a:srgbClr val="28251D"/>
                 </a:solidFill>
@@ -8084,7 +7834,7 @@
               </a:rPr>
               <a:t>Sealed evidence pack. Hand it to anyone. They verify it themselves.</a:t>
             </a:r>
-            <a:endParaRPr lang="en-US" sz="1200" dirty="0"/>
+            <a:endParaRPr lang="en-US" sz="1300" dirty="0"/>
           </a:p>
         </p:txBody>
       </p:sp>
@@ -8096,8 +7846,8 @@
         </p:nvSpPr>
         <p:spPr>
           <a:xfrm>
-            <a:off x="6263640" y="4663440"/>
-            <a:ext cx="5577840" cy="1188720"/>
+            <a:off x="6263640" y="5084064"/>
+            <a:ext cx="5577840" cy="1325880"/>
           </a:xfrm>
           <a:prstGeom prst="rect">
             <a:avLst/>
@@ -8121,24 +7871,24 @@
         </p:nvSpPr>
         <p:spPr>
           <a:xfrm>
-            <a:off x="6537960" y="4800600"/>
-            <a:ext cx="5029200" cy="411480"/>
-          </a:xfrm>
-          <a:prstGeom prst="rect">
-            <a:avLst/>
-          </a:prstGeom>
-          <a:noFill/>
-          <a:ln/>
-        </p:spPr>
-        <p:txBody>
-          <a:bodyPr wrap="square" rtlCol="0" anchor="ctr"/>
-          <a:lstStyle/>
-          <a:p>
-            <a:pPr indent="0" marL="0">
-              <a:buNone/>
-            </a:pPr>
-            <a:r>
-              <a:rPr lang="en-US" sz="1700" b="1" dirty="0">
+            <a:off x="6537960" y="5248656"/>
+            <a:ext cx="5029200" cy="457200"/>
+          </a:xfrm>
+          <a:prstGeom prst="rect">
+            <a:avLst/>
+          </a:prstGeom>
+          <a:noFill/>
+          <a:ln/>
+        </p:spPr>
+        <p:txBody>
+          <a:bodyPr wrap="square" rtlCol="0" anchor="ctr"/>
+          <a:lstStyle/>
+          <a:p>
+            <a:pPr indent="0" marL="0">
+              <a:buNone/>
+            </a:pPr>
+            <a:r>
+              <a:rPr lang="en-US" sz="1800" b="1" dirty="0">
                 <a:solidFill>
                   <a:srgbClr val="01696F"/>
                 </a:solidFill>
@@ -8148,7 +7898,7 @@
               </a:rPr>
               <a:t>replay_case</a:t>
             </a:r>
-            <a:endParaRPr lang="en-US" sz="1700" dirty="0"/>
+            <a:endParaRPr lang="en-US" sz="1800" dirty="0"/>
           </a:p>
         </p:txBody>
       </p:sp>
@@ -8160,24 +7910,24 @@
         </p:nvSpPr>
         <p:spPr>
           <a:xfrm>
-            <a:off x="6537960" y="5257800"/>
-            <a:ext cx="5029200" cy="502920"/>
-          </a:xfrm>
-          <a:prstGeom prst="rect">
-            <a:avLst/>
-          </a:prstGeom>
-          <a:noFill/>
-          <a:ln/>
-        </p:spPr>
-        <p:txBody>
-          <a:bodyPr wrap="square" rtlCol="0" anchor="ctr"/>
-          <a:lstStyle/>
-          <a:p>
-            <a:pPr indent="0" marL="0">
-              <a:buNone/>
-            </a:pPr>
-            <a:r>
-              <a:rPr lang="en-US" sz="1200" dirty="0">
+            <a:off x="6537960" y="5769864"/>
+            <a:ext cx="5029200" cy="594360"/>
+          </a:xfrm>
+          <a:prstGeom prst="rect">
+            <a:avLst/>
+          </a:prstGeom>
+          <a:noFill/>
+          <a:ln/>
+        </p:spPr>
+        <p:txBody>
+          <a:bodyPr wrap="square" rtlCol="0" anchor="ctr"/>
+          <a:lstStyle/>
+          <a:p>
+            <a:pPr indent="0" marL="0">
+              <a:buNone/>
+            </a:pPr>
+            <a:r>
+              <a:rPr lang="en-US" sz="1300" dirty="0">
                 <a:solidFill>
                   <a:srgbClr val="28251D"/>
                 </a:solidFill>
@@ -8187,73 +7937,13 @@
               </a:rPr>
               <a:t>Reconstruct any decision end to end, with full provenance.</a:t>
             </a:r>
-            <a:endParaRPr lang="en-US" sz="1200" dirty="0"/>
+            <a:endParaRPr lang="en-US" sz="1300" dirty="0"/>
           </a:p>
         </p:txBody>
       </p:sp>
       <p:sp>
         <p:nvSpPr>
           <p:cNvPr id="22" name="Text 20"/>
-          <p:cNvSpPr/>
-          <p:nvPr/>
-        </p:nvSpPr>
-        <p:spPr>
-          <a:xfrm>
-            <a:off x="548640" y="6126480"/>
-            <a:ext cx="11064240" cy="274320"/>
-          </a:xfrm>
-          <a:prstGeom prst="rect">
-            <a:avLst/>
-          </a:prstGeom>
-          <a:noFill/>
-          <a:ln/>
-        </p:spPr>
-        <p:txBody>
-          <a:bodyPr wrap="square" rtlCol="0" anchor="ctr"/>
-          <a:lstStyle/>
-          <a:p>
-            <a:pPr indent="0" marL="0">
-              <a:buNone/>
-            </a:pPr>
-            <a:r>
-              <a:rPr lang="en-US" sz="1100" dirty="0">
-                <a:solidFill>
-                  <a:srgbClr val="01696F"/>
-                </a:solidFill>
-                <a:latin typeface="Calibri" pitchFamily="34" charset="0"/>
-                <a:ea typeface="Calibri" pitchFamily="34" charset="-122"/>
-                <a:cs typeface="Calibri" pitchFamily="34" charset="-120"/>
-              </a:rPr>
-              <a:t>Browse the MCP server code: </a:t>
-            </a:r>
-            <a:pPr indent="0" marL="0">
-              <a:buNone/>
-            </a:pPr>
-            <a:r>
-              <a:rPr lang="en-US" sz="1100" u="sng" dirty="0">
-                <a:solidFill>
-                  <a:srgbClr val="01696F"/>
-                </a:solidFill>
-                <a:latin typeface="Calibri" pitchFamily="34" charset="0"/>
-                <a:ea typeface="Calibri" pitchFamily="34" charset="-122"/>
-                <a:cs typeface="Calibri" pitchFamily="34" charset="-120"/>
-                <a:hlinkClick r:id="rId1" invalidUrl="" action="" tgtFrame="" tooltip="mcp-public" history="1" highlightClick="0" endSnd="0">
-                  <a:extLst>
-                    <a:ext uri="{A12FA001-AC4F-418D-AE19-62706E023703}">
-                      <ahyp:hlinkClr xmlns:ahyp="http://schemas.microsoft.com/office/drawing/2018/hyperlinkcolor" val="tx"/>
-                    </a:ext>
-                  </a:extLst>
-                </a:hlinkClick>
-              </a:rPr>
-              <a:t>github.com/bobrapp/aigovops-beacon/tree/main/mcp-public</a:t>
-            </a:r>
-            <a:endParaRPr lang="en-US" sz="1100" dirty="0"/>
-          </a:p>
-        </p:txBody>
-      </p:sp>
-      <p:sp>
-        <p:nvSpPr>
-          <p:cNvPr id="23" name="Text 21"/>
           <p:cNvSpPr/>
           <p:nvPr/>
         </p:nvSpPr>
@@ -8284,7 +7974,7 @@
                 <a:ea typeface="Calibri" pitchFamily="34" charset="-122"/>
                 <a:cs typeface="Calibri" pitchFamily="34" charset="-120"/>
               </a:rPr>
-              <a:t>Beacon · v2.5 · Small</a:t>
+              <a:t>Beacon · v2.3</a:t>
             </a:r>
             <a:endParaRPr lang="en-US" sz="900" dirty="0"/>
           </a:p>
@@ -8292,7 +7982,7 @@
       </p:sp>
       <p:sp>
         <p:nvSpPr>
-          <p:cNvPr id="24" name="Text 22"/>
+          <p:cNvPr id="23" name="Text 21"/>
           <p:cNvSpPr/>
           <p:nvPr/>
         </p:nvSpPr>
@@ -8589,8 +8279,8 @@
         </p:nvSpPr>
         <p:spPr>
           <a:xfrm>
-            <a:off x="655168" y="5074920"/>
-            <a:ext cx="3108960" cy="320040"/>
+            <a:off x="655168" y="5440680"/>
+            <a:ext cx="3108960" cy="365760"/>
           </a:xfrm>
           <a:prstGeom prst="rect">
             <a:avLst/>
@@ -8622,53 +8312,7 @@
       </p:sp>
       <p:sp>
         <p:nvSpPr>
-          <p:cNvPr id="9" name="Text 7"/>
-          <p:cNvSpPr/>
-          <p:nvPr/>
-        </p:nvSpPr>
-        <p:spPr>
-          <a:xfrm>
-            <a:off x="655168" y="5440680"/>
-            <a:ext cx="3108960" cy="292608"/>
-          </a:xfrm>
-          <a:prstGeom prst="rect">
-            <a:avLst/>
-          </a:prstGeom>
-          <a:noFill/>
-          <a:ln/>
-        </p:spPr>
-        <p:txBody>
-          <a:bodyPr wrap="square" rtlCol="0" anchor="ctr"/>
-          <a:lstStyle/>
-          <a:p>
-            <a:pPr indent="0" marL="0">
-              <a:buNone/>
-            </a:pPr>
-            <a:r>
-              <a:rPr lang="en-US" sz="1100" u="sng" dirty="0">
-                <a:solidFill>
-                  <a:srgbClr val="01696F"/>
-                </a:solidFill>
-                <a:latin typeface="Calibri" pitchFamily="34" charset="0"/>
-                <a:ea typeface="Calibri" pitchFamily="34" charset="-122"/>
-                <a:cs typeface="Calibri" pitchFamily="34" charset="-120"/>
-                <a:hlinkClick r:id="rId1" invalidUrl="" action="" tgtFrame="" tooltip="Local desktop client" history="1" highlightClick="0" endSnd="0">
-                  <a:extLst>
-                    <a:ext uri="{A12FA001-AC4F-418D-AE19-62706E023703}">
-                      <ahyp:hlinkClr xmlns:ahyp="http://schemas.microsoft.com/office/drawing/2018/hyperlinkcolor" val="tx"/>
-                    </a:ext>
-                  </a:extLst>
-                </a:hlinkClick>
-              </a:rPr>
-              <a:t>View code →</a:t>
-            </a:r>
-            <a:endParaRPr lang="en-US" sz="1100" dirty="0"/>
-          </a:p>
-        </p:txBody>
-      </p:sp>
-      <p:sp>
-        <p:nvSpPr>
-          <p:cNvPr id="10" name="Shape 8"/>
+          <p:cNvPr id="9" name="Shape 7"/>
           <p:cNvSpPr/>
           <p:nvPr/>
         </p:nvSpPr>
@@ -8693,7 +8337,7 @@
       </p:sp>
       <p:sp>
         <p:nvSpPr>
-          <p:cNvPr id="11" name="Text 9"/>
+          <p:cNvPr id="10" name="Text 8"/>
           <p:cNvSpPr/>
           <p:nvPr/>
         </p:nvSpPr>
@@ -8732,7 +8376,7 @@
       </p:sp>
       <p:sp>
         <p:nvSpPr>
-          <p:cNvPr id="12" name="Text 10"/>
+          <p:cNvPr id="11" name="Text 9"/>
           <p:cNvSpPr/>
           <p:nvPr/>
         </p:nvSpPr>
@@ -8771,7 +8415,7 @@
       </p:sp>
       <p:sp>
         <p:nvSpPr>
-          <p:cNvPr id="13" name="Text 11"/>
+          <p:cNvPr id="12" name="Text 10"/>
           <p:cNvSpPr/>
           <p:nvPr/>
         </p:nvSpPr>
@@ -8810,14 +8454,14 @@
       </p:sp>
       <p:sp>
         <p:nvSpPr>
-          <p:cNvPr id="14" name="Text 12"/>
-          <p:cNvSpPr/>
-          <p:nvPr/>
-        </p:nvSpPr>
-        <p:spPr>
-          <a:xfrm>
-            <a:off x="4541368" y="5074920"/>
-            <a:ext cx="3108960" cy="320040"/>
+          <p:cNvPr id="13" name="Text 11"/>
+          <p:cNvSpPr/>
+          <p:nvPr/>
+        </p:nvSpPr>
+        <p:spPr>
+          <a:xfrm>
+            <a:off x="4541368" y="5440680"/>
+            <a:ext cx="3108960" cy="365760"/>
           </a:xfrm>
           <a:prstGeom prst="rect">
             <a:avLst/>
@@ -8849,53 +8493,7 @@
       </p:sp>
       <p:sp>
         <p:nvSpPr>
-          <p:cNvPr id="15" name="Text 13"/>
-          <p:cNvSpPr/>
-          <p:nvPr/>
-        </p:nvSpPr>
-        <p:spPr>
-          <a:xfrm>
-            <a:off x="4541368" y="5440680"/>
-            <a:ext cx="3108960" cy="292608"/>
-          </a:xfrm>
-          <a:prstGeom prst="rect">
-            <a:avLst/>
-          </a:prstGeom>
-          <a:noFill/>
-          <a:ln/>
-        </p:spPr>
-        <p:txBody>
-          <a:bodyPr wrap="square" rtlCol="0" anchor="ctr"/>
-          <a:lstStyle/>
-          <a:p>
-            <a:pPr indent="0" marL="0">
-              <a:buNone/>
-            </a:pPr>
-            <a:r>
-              <a:rPr lang="en-US" sz="1100" u="sng" dirty="0">
-                <a:solidFill>
-                  <a:srgbClr val="01696F"/>
-                </a:solidFill>
-                <a:latin typeface="Calibri" pitchFamily="34" charset="0"/>
-                <a:ea typeface="Calibri" pitchFamily="34" charset="-122"/>
-                <a:cs typeface="Calibri" pitchFamily="34" charset="-120"/>
-                <a:hlinkClick r:id="rId2" invalidUrl="" action="" tgtFrame="" tooltip="Hosted MCP server" history="1" highlightClick="0" endSnd="0">
-                  <a:extLst>
-                    <a:ext uri="{A12FA001-AC4F-418D-AE19-62706E023703}">
-                      <ahyp:hlinkClr xmlns:ahyp="http://schemas.microsoft.com/office/drawing/2018/hyperlinkcolor" val="tx"/>
-                    </a:ext>
-                  </a:extLst>
-                </a:hlinkClick>
-              </a:rPr>
-              <a:t>View code →</a:t>
-            </a:r>
-            <a:endParaRPr lang="en-US" sz="1100" dirty="0"/>
-          </a:p>
-        </p:txBody>
-      </p:sp>
-      <p:sp>
-        <p:nvSpPr>
-          <p:cNvPr id="16" name="Shape 14"/>
+          <p:cNvPr id="14" name="Shape 12"/>
           <p:cNvSpPr/>
           <p:nvPr/>
         </p:nvSpPr>
@@ -8920,7 +8518,7 @@
       </p:sp>
       <p:sp>
         <p:nvSpPr>
-          <p:cNvPr id="17" name="Text 15"/>
+          <p:cNvPr id="15" name="Text 13"/>
           <p:cNvSpPr/>
           <p:nvPr/>
         </p:nvSpPr>
@@ -8959,7 +8557,7 @@
       </p:sp>
       <p:sp>
         <p:nvSpPr>
-          <p:cNvPr id="18" name="Text 16"/>
+          <p:cNvPr id="16" name="Text 14"/>
           <p:cNvSpPr/>
           <p:nvPr/>
         </p:nvSpPr>
@@ -8998,7 +8596,7 @@
       </p:sp>
       <p:sp>
         <p:nvSpPr>
-          <p:cNvPr id="19" name="Text 17"/>
+          <p:cNvPr id="17" name="Text 15"/>
           <p:cNvSpPr/>
           <p:nvPr/>
         </p:nvSpPr>
@@ -9037,14 +8635,14 @@
       </p:sp>
       <p:sp>
         <p:nvSpPr>
-          <p:cNvPr id="20" name="Text 18"/>
-          <p:cNvSpPr/>
-          <p:nvPr/>
-        </p:nvSpPr>
-        <p:spPr>
-          <a:xfrm>
-            <a:off x="8427568" y="5074920"/>
-            <a:ext cx="3108960" cy="320040"/>
+          <p:cNvPr id="18" name="Text 16"/>
+          <p:cNvSpPr/>
+          <p:nvPr/>
+        </p:nvSpPr>
+        <p:spPr>
+          <a:xfrm>
+            <a:off x="8427568" y="5440680"/>
+            <a:ext cx="3108960" cy="365760"/>
           </a:xfrm>
           <a:prstGeom prst="rect">
             <a:avLst/>
@@ -9076,53 +8674,7 @@
       </p:sp>
       <p:sp>
         <p:nvSpPr>
-          <p:cNvPr id="21" name="Text 19"/>
-          <p:cNvSpPr/>
-          <p:nvPr/>
-        </p:nvSpPr>
-        <p:spPr>
-          <a:xfrm>
-            <a:off x="8427568" y="5440680"/>
-            <a:ext cx="3108960" cy="292608"/>
-          </a:xfrm>
-          <a:prstGeom prst="rect">
-            <a:avLst/>
-          </a:prstGeom>
-          <a:noFill/>
-          <a:ln/>
-        </p:spPr>
-        <p:txBody>
-          <a:bodyPr wrap="square" rtlCol="0" anchor="ctr"/>
-          <a:lstStyle/>
-          <a:p>
-            <a:pPr indent="0" marL="0">
-              <a:buNone/>
-            </a:pPr>
-            <a:r>
-              <a:rPr lang="en-US" sz="1100" u="sng" dirty="0">
-                <a:solidFill>
-                  <a:srgbClr val="01696F"/>
-                </a:solidFill>
-                <a:latin typeface="Calibri" pitchFamily="34" charset="0"/>
-                <a:ea typeface="Calibri" pitchFamily="34" charset="-122"/>
-                <a:cs typeface="Calibri" pitchFamily="34" charset="-120"/>
-                <a:hlinkClick r:id="rId3" invalidUrl="" action="" tgtFrame="" tooltip="Restricted public agent" history="1" highlightClick="0" endSnd="0">
-                  <a:extLst>
-                    <a:ext uri="{A12FA001-AC4F-418D-AE19-62706E023703}">
-                      <ahyp:hlinkClr xmlns:ahyp="http://schemas.microsoft.com/office/drawing/2018/hyperlinkcolor" val="tx"/>
-                    </a:ext>
-                  </a:extLst>
-                </a:hlinkClick>
-              </a:rPr>
-              <a:t>View code →</a:t>
-            </a:r>
-            <a:endParaRPr lang="en-US" sz="1100" dirty="0"/>
-          </a:p>
-        </p:txBody>
-      </p:sp>
-      <p:sp>
-        <p:nvSpPr>
-          <p:cNvPr id="22" name="Text 20"/>
+          <p:cNvPr id="19" name="Text 17"/>
           <p:cNvSpPr/>
           <p:nvPr/>
         </p:nvSpPr>
@@ -9153,7 +8705,7 @@
                 <a:ea typeface="Calibri" pitchFamily="34" charset="-122"/>
                 <a:cs typeface="Calibri" pitchFamily="34" charset="-120"/>
               </a:rPr>
-              <a:t>Beacon · v2.5 · Small</a:t>
+              <a:t>Beacon · v2.3</a:t>
             </a:r>
             <a:endParaRPr lang="en-US" sz="900" dirty="0"/>
           </a:p>
@@ -9161,7 +8713,7 @@
       </p:sp>
       <p:sp>
         <p:nvSpPr>
-          <p:cNvPr id="23" name="Text 21"/>
+          <p:cNvPr id="20" name="Text 18"/>
           <p:cNvSpPr/>
           <p:nvPr/>
         </p:nvSpPr>
@@ -9959,7 +9511,7 @@
                 <a:ea typeface="Calibri" pitchFamily="34" charset="-122"/>
                 <a:cs typeface="Calibri" pitchFamily="34" charset="-120"/>
               </a:rPr>
-              <a:t>Beacon · v2.5 · Small</a:t>
+              <a:t>Beacon · v2.3</a:t>
             </a:r>
             <a:endParaRPr lang="en-US" sz="900" dirty="0"/>
           </a:p>
@@ -10564,7 +10116,7 @@
                 <a:latin typeface="Calibri" pitchFamily="34" charset="0"/>
                 <a:ea typeface="Calibri" pitchFamily="34" charset="-122"/>
                 <a:cs typeface="Calibri" pitchFamily="34" charset="-120"/>
-                <a:hlinkClick r:id="rId1" invalidUrl="" action="" tgtFrame="" tooltip="Animated walkthrough" history="1" highlightClick="0" endSnd="0">
+                <a:hlinkClick r:id="rId1" invalidUrl="" action="" tgtFrame="" tooltip="" history="1" highlightClick="0" endSnd="0">
                   <a:extLst>
                     <a:ext uri="{A12FA001-AC4F-418D-AE19-62706E023703}">
                       <ahyp:hlinkClr xmlns:ahyp="http://schemas.microsoft.com/office/drawing/2018/hyperlinkcolor" val="tx"/>
@@ -10572,7 +10124,7 @@
                   </a:extLst>
                 </a:hlinkClick>
               </a:rPr>
-              <a:t>bobrapp.github.io/aigovops-beacon/walkthrough/</a:t>
+              <a:t>aigovops-foundation.github.io/aigovops-beacon/walkthrough/</a:t>
             </a:r>
             <a:endParaRPr lang="en-US" sz="1200" dirty="0"/>
           </a:p>
@@ -10611,7 +10163,7 @@
                 <a:ea typeface="Calibri" pitchFamily="34" charset="-122"/>
                 <a:cs typeface="Calibri" pitchFamily="34" charset="-120"/>
               </a:rPr>
-              <a:t>Beacon · v2.5 · Small</a:t>
+              <a:t>Beacon · v2.3</a:t>
             </a:r>
             <a:endParaRPr lang="en-US" sz="900" dirty="0"/>
           </a:p>
@@ -10855,20 +10407,13 @@
               <a:buNone/>
             </a:pPr>
             <a:r>
-              <a:rPr lang="en-US" sz="2200" b="1" u="sng" dirty="0">
+              <a:rPr lang="en-US" sz="2200" b="1" dirty="0">
                 <a:solidFill>
                   <a:srgbClr val="28251D"/>
                 </a:solidFill>
                 <a:latin typeface="Courier New" pitchFamily="34" charset="0"/>
                 <a:ea typeface="Courier New" pitchFamily="34" charset="-122"/>
                 <a:cs typeface="Courier New" pitchFamily="34" charset="-120"/>
-                <a:hlinkClick r:id="rId1" invalidUrl="" action="" tgtFrame="" tooltip="Browse the code" history="1" highlightClick="0" endSnd="0">
-                  <a:extLst>
-                    <a:ext uri="{A12FA001-AC4F-418D-AE19-62706E023703}">
-                      <ahyp:hlinkClr xmlns:ahyp="http://schemas.microsoft.com/office/drawing/2018/hyperlinkcolor" val="tx"/>
-                    </a:ext>
-                  </a:extLst>
-                </a:hlinkClick>
               </a:rPr>
               <a:t>mcp-public/</a:t>
             </a:r>
@@ -11160,20 +10705,13 @@
               <a:buNone/>
             </a:pPr>
             <a:r>
-              <a:rPr lang="en-US" sz="2200" b="1" u="sng" dirty="0">
+              <a:rPr lang="en-US" sz="2200" b="1" dirty="0">
                 <a:solidFill>
                   <a:srgbClr val="28251D"/>
                 </a:solidFill>
                 <a:latin typeface="Courier New" pitchFamily="34" charset="0"/>
                 <a:ea typeface="Courier New" pitchFamily="34" charset="-122"/>
                 <a:cs typeface="Courier New" pitchFamily="34" charset="-120"/>
-                <a:hlinkClick r:id="rId2" invalidUrl="" action="" tgtFrame="" tooltip="Browse the code" history="1" highlightClick="0" endSnd="0">
-                  <a:extLst>
-                    <a:ext uri="{A12FA001-AC4F-418D-AE19-62706E023703}">
-                      <ahyp:hlinkClr xmlns:ahyp="http://schemas.microsoft.com/office/drawing/2018/hyperlinkcolor" val="tx"/>
-                    </a:ext>
-                  </a:extLst>
-                </a:hlinkClick>
               </a:rPr>
               <a:t>agent/</a:t>
             </a:r>
@@ -11409,7 +10947,7 @@
                 <a:ea typeface="Calibri" pitchFamily="34" charset="-122"/>
                 <a:cs typeface="Calibri" pitchFamily="34" charset="-120"/>
               </a:rPr>
-              <a:t>Beacon · v2.5 · Small</a:t>
+              <a:t>Beacon · v2.3</a:t>
             </a:r>
             <a:endParaRPr lang="en-US" sz="900" dirty="0"/>
           </a:p>

</xml_diff>